<commit_message>
Consolida etapas 7.31 e 7.32 e documentação Modbus Rev.01
</commit_message>
<xml_diff>
--- a/AUTOPACKLINE_APRESENTACAO.pptx
+++ b/AUTOPACKLINE_APRESENTACAO.pptx
@@ -2252,7 +2252,7 @@
         </p:nvSpPr>
         <p:spPr>
           <a:xfrm>
-            <a:off x="876300" y="1066800"/>
+            <a:off x="881062" y="1002770"/>
             <a:ext cx="10429875" cy="4333875"/>
           </a:xfrm>
           <a:prstGeom prst="roundRect">
@@ -2356,8 +2356,38 @@
         </p:blipFill>
         <p:spPr>
           <a:xfrm>
-            <a:off x="2227906" y="1130830"/>
-            <a:ext cx="7564737" cy="4253440"/>
+            <a:off x="914400" y="1130830"/>
+            <a:ext cx="6912077" cy="4080267"/>
+          </a:xfrm>
+          <a:prstGeom prst="rect">
+            <a:avLst/>
+          </a:prstGeom>
+        </p:spPr>
+      </p:pic>
+      <p:pic>
+        <p:nvPicPr>
+          <p:cNvPr id="11" name="Imagem 10">
+            <a:extLst>
+              <a:ext uri="{FF2B5EF4-FFF2-40B4-BE49-F238E27FC236}">
+                <a16:creationId xmlns:a16="http://schemas.microsoft.com/office/drawing/2014/main" id="{9079A76B-96EB-8BAE-0C1D-F05D8ED02E3C}"/>
+              </a:ext>
+            </a:extLst>
+          </p:cNvPr>
+          <p:cNvPicPr>
+            <a:picLocks noChangeAspect="1"/>
+          </p:cNvPicPr>
+          <p:nvPr/>
+        </p:nvPicPr>
+        <p:blipFill>
+          <a:blip r:embed="rId5"/>
+          <a:stretch>
+            <a:fillRect/>
+          </a:stretch>
+        </p:blipFill>
+        <p:spPr>
+          <a:xfrm>
+            <a:off x="7826477" y="1083204"/>
+            <a:ext cx="3309630" cy="4253439"/>
           </a:xfrm>
           <a:prstGeom prst="rect">
             <a:avLst/>

</xml_diff>